<commit_message>
Added presentation slides - v7-v8
</commit_message>
<xml_diff>
--- a/mini-conference/Flow_Gentrification_Deck_v7_20260705.pptx
+++ b/mini-conference/Flow_Gentrification_Deck_v7_20260705.pptx
@@ -2,26 +2,26 @@
 <file path=ppt/presentation.xml><?xml version="1.0" encoding="utf-8"?>
 <p:presentation xmlns:a="http://schemas.openxmlformats.org/drawingml/2006/main" xmlns:r="http://schemas.openxmlformats.org/officeDocument/2006/relationships" xmlns:mc="http://schemas.openxmlformats.org/markup-compatibility/2006" xmlns:mv="urn:schemas-microsoft-com:mac:vml" xmlns:p="http://schemas.openxmlformats.org/presentationml/2006/main" xmlns:c="http://schemas.openxmlformats.org/drawingml/2006/chart" xmlns:dgm="http://schemas.openxmlformats.org/drawingml/2006/diagram" xmlns:o="urn:schemas-microsoft-com:office:office" xmlns:v="urn:schemas-microsoft-com:vml" xmlns:pvml="urn:schemas-microsoft-com:office:powerpoint" xmlns:com="http://schemas.openxmlformats.org/drawingml/2006/compatibility" xmlns:p14="http://schemas.microsoft.com/office/powerpoint/2010/main" xmlns:p15="http://schemas.microsoft.com/office/powerpoint/2012/main" xmlns:ahyp="http://schemas.microsoft.com/office/drawing/2018/hyperlinkcolor" autoCompressPictures="0" strictFirstAndLastChars="0" saveSubsetFonts="1">
   <p:sldMasterIdLst>
-    <p:sldMasterId id="2147483649" r:id="rId3"/>
+    <p:sldMasterId id="2147483649" r:id="rId4"/>
   </p:sldMasterIdLst>
   <p:notesMasterIdLst>
-    <p:notesMasterId r:id="rId4"/>
+    <p:notesMasterId r:id="rId5"/>
   </p:notesMasterIdLst>
   <p:sldIdLst>
-    <p:sldId id="256" r:id="rId5"/>
-    <p:sldId id="257" r:id="rId6"/>
-    <p:sldId id="258" r:id="rId7"/>
-    <p:sldId id="259" r:id="rId8"/>
-    <p:sldId id="260" r:id="rId9"/>
-    <p:sldId id="261" r:id="rId10"/>
-    <p:sldId id="262" r:id="rId11"/>
-    <p:sldId id="263" r:id="rId12"/>
-    <p:sldId id="264" r:id="rId13"/>
-    <p:sldId id="265" r:id="rId14"/>
-    <p:sldId id="266" r:id="rId15"/>
-    <p:sldId id="267" r:id="rId16"/>
-    <p:sldId id="268" r:id="rId17"/>
-    <p:sldId id="269" r:id="rId18"/>
+    <p:sldId id="256" r:id="rId6"/>
+    <p:sldId id="257" r:id="rId7"/>
+    <p:sldId id="258" r:id="rId8"/>
+    <p:sldId id="259" r:id="rId9"/>
+    <p:sldId id="260" r:id="rId10"/>
+    <p:sldId id="261" r:id="rId11"/>
+    <p:sldId id="262" r:id="rId12"/>
+    <p:sldId id="263" r:id="rId13"/>
+    <p:sldId id="264" r:id="rId14"/>
+    <p:sldId id="265" r:id="rId15"/>
+    <p:sldId id="266" r:id="rId16"/>
+    <p:sldId id="267" r:id="rId17"/>
+    <p:sldId id="268" r:id="rId18"/>
+    <p:sldId id="269" r:id="rId19"/>
   </p:sldIdLst>
   <p:sldSz cy="5143500" cx="9144000"/>
   <p:notesSz cx="5143500" cy="9144000"/>
@@ -255,6 +255,83 @@
     </a:lvl9pPr>
   </p:defaultTextStyle>
 </p:presentation>
+</file>
+
+<file path=ppt/commentAuthors.xml><?xml version="1.0" encoding="utf-8"?>
+<p:cmAuthorLst xmlns:a="http://schemas.openxmlformats.org/drawingml/2006/main" xmlns:r="http://schemas.openxmlformats.org/officeDocument/2006/relationships" xmlns:mc="http://schemas.openxmlformats.org/markup-compatibility/2006" xmlns:mv="urn:schemas-microsoft-com:mac:vml" xmlns:p="http://schemas.openxmlformats.org/presentationml/2006/main" xmlns:c="http://schemas.openxmlformats.org/drawingml/2006/chart" xmlns:dgm="http://schemas.openxmlformats.org/drawingml/2006/diagram" xmlns:o="urn:schemas-microsoft-com:office:office" xmlns:v="urn:schemas-microsoft-com:vml" xmlns:pvml="urn:schemas-microsoft-com:office:powerpoint" xmlns:com="http://schemas.openxmlformats.org/drawingml/2006/compatibility" xmlns:p14="http://schemas.microsoft.com/office/powerpoint/2010/main" xmlns:p15="http://schemas.microsoft.com/office/powerpoint/2012/main" xmlns:ahyp="http://schemas.microsoft.com/office/drawing/2018/hyperlinkcolor">
+  <p:cmAuthor clrIdx="0" id="0" initials="" lastIdx="9" name="Yujing Xing"/>
+</p:cmAuthorLst>
+</file>
+
+<file path=ppt/comments/comment1.xml><?xml version="1.0" encoding="utf-8"?>
+<p:cmLst xmlns:a="http://schemas.openxmlformats.org/drawingml/2006/main" xmlns:r="http://schemas.openxmlformats.org/officeDocument/2006/relationships" xmlns:mc="http://schemas.openxmlformats.org/markup-compatibility/2006" xmlns:mv="urn:schemas-microsoft-com:mac:vml" xmlns:p="http://schemas.openxmlformats.org/presentationml/2006/main" xmlns:c="http://schemas.openxmlformats.org/drawingml/2006/chart" xmlns:dgm="http://schemas.openxmlformats.org/drawingml/2006/diagram" xmlns:o="urn:schemas-microsoft-com:office:office" xmlns:v="urn:schemas-microsoft-com:vml" xmlns:pvml="urn:schemas-microsoft-com:office:powerpoint" xmlns:com="http://schemas.openxmlformats.org/drawingml/2006/compatibility" xmlns:p14="http://schemas.microsoft.com/office/powerpoint/2010/main" xmlns:p15="http://schemas.microsoft.com/office/powerpoint/2012/main" xmlns:ahyp="http://schemas.microsoft.com/office/drawing/2018/hyperlinkcolor">
+  <p:cm authorId="0" idx="1" dt="2026-07-05T23:06:46.985">
+    <p:pos x="460" y="737"/>
+    <p:text>Title "Where do they go?"</p:text>
+  </p:cm>
+</p:cmLst>
+</file>
+
+<file path=ppt/comments/comment2.xml><?xml version="1.0" encoding="utf-8"?>
+<p:cmLst xmlns:a="http://schemas.openxmlformats.org/drawingml/2006/main" xmlns:r="http://schemas.openxmlformats.org/officeDocument/2006/relationships" xmlns:mc="http://schemas.openxmlformats.org/markup-compatibility/2006" xmlns:mv="urn:schemas-microsoft-com:mac:vml" xmlns:p="http://schemas.openxmlformats.org/presentationml/2006/main" xmlns:c="http://schemas.openxmlformats.org/drawingml/2006/chart" xmlns:dgm="http://schemas.openxmlformats.org/drawingml/2006/diagram" xmlns:o="urn:schemas-microsoft-com:office:office" xmlns:v="urn:schemas-microsoft-com:vml" xmlns:pvml="urn:schemas-microsoft-com:office:powerpoint" xmlns:com="http://schemas.openxmlformats.org/drawingml/2006/compatibility" xmlns:p14="http://schemas.microsoft.com/office/powerpoint/2010/main" xmlns:p15="http://schemas.microsoft.com/office/powerpoint/2012/main" xmlns:ahyp="http://schemas.microsoft.com/office/drawing/2018/hyperlinkcolor">
+  <p:cm authorId="0" idx="2" dt="2026-07-05T22:45:15.865">
+    <p:pos x="316" y="921"/>
+    <p:text>make slide 4 in v6 to cover both boxes in this slide</p:text>
+  </p:cm>
+</p:cmLst>
+</file>
+
+<file path=ppt/comments/comment3.xml><?xml version="1.0" encoding="utf-8"?>
+<p:cmLst xmlns:a="http://schemas.openxmlformats.org/drawingml/2006/main" xmlns:r="http://schemas.openxmlformats.org/officeDocument/2006/relationships" xmlns:mc="http://schemas.openxmlformats.org/markup-compatibility/2006" xmlns:mv="urn:schemas-microsoft-com:mac:vml" xmlns:p="http://schemas.openxmlformats.org/presentationml/2006/main" xmlns:c="http://schemas.openxmlformats.org/drawingml/2006/chart" xmlns:dgm="http://schemas.openxmlformats.org/drawingml/2006/diagram" xmlns:o="urn:schemas-microsoft-com:office:office" xmlns:v="urn:schemas-microsoft-com:vml" xmlns:pvml="urn:schemas-microsoft-com:office:powerpoint" xmlns:com="http://schemas.openxmlformats.org/drawingml/2006/compatibility" xmlns:p14="http://schemas.microsoft.com/office/powerpoint/2010/main" xmlns:p15="http://schemas.microsoft.com/office/powerpoint/2012/main" xmlns:ahyp="http://schemas.microsoft.com/office/drawing/2018/hyperlinkcolor">
+  <p:cm authorId="0" idx="3" dt="2026-07-05T22:44:37.939">
+    <p:pos x="316" y="161"/>
+    <p:text>Add map results for findings</p:text>
+  </p:cm>
+</p:cmLst>
+</file>
+
+<file path=ppt/comments/comment4.xml><?xml version="1.0" encoding="utf-8"?>
+<p:cmLst xmlns:a="http://schemas.openxmlformats.org/drawingml/2006/main" xmlns:r="http://schemas.openxmlformats.org/officeDocument/2006/relationships" xmlns:mc="http://schemas.openxmlformats.org/markup-compatibility/2006" xmlns:mv="urn:schemas-microsoft-com:mac:vml" xmlns:p="http://schemas.openxmlformats.org/presentationml/2006/main" xmlns:c="http://schemas.openxmlformats.org/drawingml/2006/chart" xmlns:dgm="http://schemas.openxmlformats.org/drawingml/2006/diagram" xmlns:o="urn:schemas-microsoft-com:office:office" xmlns:v="urn:schemas-microsoft-com:vml" xmlns:pvml="urn:schemas-microsoft-com:office:powerpoint" xmlns:com="http://schemas.openxmlformats.org/drawingml/2006/compatibility" xmlns:p14="http://schemas.microsoft.com/office/powerpoint/2010/main" xmlns:p15="http://schemas.microsoft.com/office/powerpoint/2012/main" xmlns:ahyp="http://schemas.microsoft.com/office/drawing/2018/hyperlinkcolor">
+  <p:cm authorId="0" idx="4" dt="2026-07-05T22:46:51.176">
+    <p:pos x="316" y="299"/>
+    <p:text>Too many words!!! For all finding slides.</p:text>
+  </p:cm>
+  <p:cm authorId="0" idx="5" dt="2026-07-05T23:00:31.265">
+    <p:pos x="316" y="399"/>
+    <p:text>I think we need the tree pipeline diagram here.</p:text>
+  </p:cm>
+</p:cmLst>
+</file>
+
+<file path=ppt/comments/comment5.xml><?xml version="1.0" encoding="utf-8"?>
+<p:cmLst xmlns:a="http://schemas.openxmlformats.org/drawingml/2006/main" xmlns:r="http://schemas.openxmlformats.org/officeDocument/2006/relationships" xmlns:mc="http://schemas.openxmlformats.org/markup-compatibility/2006" xmlns:mv="urn:schemas-microsoft-com:mac:vml" xmlns:p="http://schemas.openxmlformats.org/presentationml/2006/main" xmlns:c="http://schemas.openxmlformats.org/drawingml/2006/chart" xmlns:dgm="http://schemas.openxmlformats.org/drawingml/2006/diagram" xmlns:o="urn:schemas-microsoft-com:office:office" xmlns:v="urn:schemas-microsoft-com:vml" xmlns:pvml="urn:schemas-microsoft-com:office:powerpoint" xmlns:com="http://schemas.openxmlformats.org/drawingml/2006/compatibility" xmlns:p14="http://schemas.microsoft.com/office/powerpoint/2010/main" xmlns:p15="http://schemas.microsoft.com/office/powerpoint/2012/main" xmlns:ahyp="http://schemas.microsoft.com/office/drawing/2018/hyperlinkcolor">
+  <p:cm authorId="0" idx="6" dt="2026-07-05T22:49:33.489">
+    <p:pos x="316" y="1140"/>
+    <p:text>make the number and the line separated, now they're overlapping.</p:text>
+  </p:cm>
+</p:cmLst>
+</file>
+
+<file path=ppt/comments/comment6.xml><?xml version="1.0" encoding="utf-8"?>
+<p:cmLst xmlns:a="http://schemas.openxmlformats.org/drawingml/2006/main" xmlns:r="http://schemas.openxmlformats.org/officeDocument/2006/relationships" xmlns:mc="http://schemas.openxmlformats.org/markup-compatibility/2006" xmlns:mv="urn:schemas-microsoft-com:mac:vml" xmlns:p="http://schemas.openxmlformats.org/presentationml/2006/main" xmlns:c="http://schemas.openxmlformats.org/drawingml/2006/chart" xmlns:dgm="http://schemas.openxmlformats.org/drawingml/2006/diagram" xmlns:o="urn:schemas-microsoft-com:office:office" xmlns:v="urn:schemas-microsoft-com:vml" xmlns:pvml="urn:schemas-microsoft-com:office:powerpoint" xmlns:com="http://schemas.openxmlformats.org/drawingml/2006/compatibility" xmlns:p14="http://schemas.microsoft.com/office/powerpoint/2010/main" xmlns:p15="http://schemas.microsoft.com/office/powerpoint/2012/main" xmlns:ahyp="http://schemas.microsoft.com/office/drawing/2018/hyperlinkcolor">
+  <p:cm authorId="0" idx="7" dt="2026-07-05T22:51:46.979">
+    <p:pos x="316" y="334"/>
+    <p:text>Why this is a failure? We should expect a different definition, so naturally they're not equivalent?</p:text>
+  </p:cm>
+</p:cmLst>
+</file>
+
+<file path=ppt/comments/comment7.xml><?xml version="1.0" encoding="utf-8"?>
+<p:cmLst xmlns:a="http://schemas.openxmlformats.org/drawingml/2006/main" xmlns:r="http://schemas.openxmlformats.org/officeDocument/2006/relationships" xmlns:mc="http://schemas.openxmlformats.org/markup-compatibility/2006" xmlns:mv="urn:schemas-microsoft-com:mac:vml" xmlns:p="http://schemas.openxmlformats.org/presentationml/2006/main" xmlns:c="http://schemas.openxmlformats.org/drawingml/2006/chart" xmlns:dgm="http://schemas.openxmlformats.org/drawingml/2006/diagram" xmlns:o="urn:schemas-microsoft-com:office:office" xmlns:v="urn:schemas-microsoft-com:vml" xmlns:pvml="urn:schemas-microsoft-com:office:powerpoint" xmlns:com="http://schemas.openxmlformats.org/drawingml/2006/compatibility" xmlns:p14="http://schemas.microsoft.com/office/powerpoint/2010/main" xmlns:p15="http://schemas.microsoft.com/office/powerpoint/2012/main" xmlns:ahyp="http://schemas.microsoft.com/office/drawing/2018/hyperlinkcolor">
+  <p:cm authorId="0" idx="8" dt="2026-07-05T22:52:26.570">
+    <p:pos x="432" y="990"/>
+    <p:text>I think we can give 3 alluvial plots as appendix?</p:text>
+  </p:cm>
+  <p:cm authorId="0" idx="9" dt="2026-07-05T23:08:23.195">
+    <p:pos x="432" y="1900"/>
+    <p:text>I don't think this is artefact? People can just prefer staying within London?</p:text>
+  </p:cm>
+</p:cmLst>
 </file>
 
 <file path=ppt/notesMasters/notesMaster1.xml><?xml version="1.0" encoding="utf-8"?>
@@ -4521,7 +4598,19 @@
                 <a:cs typeface="Cambria"/>
                 <a:sym typeface="Cambria"/>
               </a:rPr>
-              <a:t>Testing a Flow-Based Definition of Gentrification</a:t>
+              <a:t>Testing</a:t>
+            </a:r>
+            <a:r>
+              <a:rPr b="1" i="0" lang="en-US" sz="3400" u="none" cap="none" strike="noStrike">
+                <a:solidFill>
+                  <a:srgbClr val="FFFFFF"/>
+                </a:solidFill>
+                <a:latin typeface="Cambria"/>
+                <a:ea typeface="Cambria"/>
+                <a:cs typeface="Cambria"/>
+                <a:sym typeface="Cambria"/>
+              </a:rPr>
+              <a:t> a Flow-Based Definition of Gentrification</a:t>
             </a:r>
             <a:endParaRPr b="0" i="0" sz="3400" u="none" cap="none" strike="noStrike">
               <a:solidFill>
@@ -5299,7 +5388,7 @@
               <a:buNone/>
             </a:pPr>
             <a:r>
-              <a:rPr b="1" i="0" lang="en-US" sz="2500" u="none" cap="none" strike="noStrike">
+              <a:rPr b="1" i="0" lang="en-US" sz="2300" u="none" cap="none" strike="noStrike">
                 <a:solidFill>
                   <a:srgbClr val="2B2B31"/>
                 </a:solidFill>
@@ -5310,7 +5399,7 @@
               </a:rPr>
               <a:t>Gentrification’s subtypes separate by mechanism</a:t>
             </a:r>
-            <a:endParaRPr b="0" i="0" sz="2500" u="none" cap="none" strike="noStrike">
+            <a:endParaRPr b="0" i="0" sz="2300" u="none" cap="none" strike="noStrike">
               <a:solidFill>
                 <a:schemeClr val="dk1"/>
               </a:solidFill>
@@ -6406,7 +6495,7 @@
               <a:buNone/>
             </a:pPr>
             <a:r>
-              <a:rPr b="1" i="0" lang="en-US" sz="2500" u="none" cap="none" strike="noStrike">
+              <a:rPr b="1" i="0" lang="en-US" sz="2300" u="none" cap="none" strike="noStrike">
                 <a:solidFill>
                   <a:srgbClr val="FFFFFF"/>
                 </a:solidFill>
@@ -6415,9 +6504,21 @@
                 <a:cs typeface="Cambria"/>
                 <a:sym typeface="Cambria"/>
               </a:rPr>
-              <a:t>Fails as an equivalence — survives as a signature</a:t>
-            </a:r>
-            <a:endParaRPr b="0" i="0" sz="2500" u="none" cap="none" strike="noStrike">
+              <a:t>Fails as an equivalence</a:t>
+            </a:r>
+            <a:r>
+              <a:rPr b="1" i="0" lang="en-US" sz="2300" u="none" cap="none" strike="noStrike">
+                <a:solidFill>
+                  <a:srgbClr val="FFFFFF"/>
+                </a:solidFill>
+                <a:latin typeface="Cambria"/>
+                <a:ea typeface="Cambria"/>
+                <a:cs typeface="Cambria"/>
+                <a:sym typeface="Cambria"/>
+              </a:rPr>
+              <a:t> — survives as a signature</a:t>
+            </a:r>
+            <a:endParaRPr b="0" i="0" sz="2300" u="none" cap="none" strike="noStrike">
               <a:solidFill>
                 <a:schemeClr val="dk1"/>
               </a:solidFill>
@@ -7196,7 +7297,7 @@
               <a:buNone/>
             </a:pPr>
             <a:r>
-              <a:rPr b="1" i="0" lang="en-US" sz="2500" u="none" cap="none" strike="noStrike">
+              <a:rPr b="1" i="0" lang="en-US" sz="2300" u="none" cap="none" strike="noStrike">
                 <a:solidFill>
                   <a:srgbClr val="2B2B31"/>
                 </a:solidFill>
@@ -7207,7 +7308,7 @@
               </a:rPr>
               <a:t>What this adds — and what it can’t say</a:t>
             </a:r>
-            <a:endParaRPr b="0" i="0" sz="2500" u="none" cap="none" strike="noStrike">
+            <a:endParaRPr b="0" i="0" sz="2300" u="none" cap="none" strike="noStrike">
               <a:solidFill>
                 <a:schemeClr val="dk1"/>
               </a:solidFill>
@@ -9338,7 +9439,7 @@
               <a:buNone/>
             </a:pPr>
             <a:r>
-              <a:rPr b="1" i="0" lang="en-US" sz="2500" u="none" cap="none" strike="noStrike">
+              <a:rPr b="1" i="0" lang="en-US" sz="2300" u="none" cap="none" strike="noStrike">
                 <a:solidFill>
                   <a:srgbClr val="2B2B31"/>
                 </a:solidFill>
@@ -9349,7 +9450,7 @@
               </a:rPr>
               <a:t>Four neighbourhoods, four mechanisms</a:t>
             </a:r>
-            <a:endParaRPr b="0" i="0" sz="2500" u="none" cap="none" strike="noStrike">
+            <a:endParaRPr b="0" i="0" sz="2300" u="none" cap="none" strike="noStrike">
               <a:solidFill>
                 <a:schemeClr val="dk1"/>
               </a:solidFill>
@@ -9899,7 +10000,31 @@
                 <a:cs typeface="Calibri"/>
                 <a:sym typeface="Calibri"/>
               </a:rPr>
-              <a:t>inflow-driven in both years (2 of only 8 city-wide); affluent-in AND poorer-out both thick, frame-robust. Yee-modal Stable — the flow lens sees what attributes miss.</a:t>
+              <a:t>inflow-driven in </a:t>
+            </a:r>
+            <a:r>
+              <a:rPr b="0" i="0" lang="en-US" sz="900" u="none" cap="none" strike="noStrike">
+                <a:solidFill>
+                  <a:srgbClr val="FFFFFF"/>
+                </a:solidFill>
+                <a:latin typeface="Calibri"/>
+                <a:ea typeface="Calibri"/>
+                <a:cs typeface="Calibri"/>
+                <a:sym typeface="Calibri"/>
+              </a:rPr>
+              <a:t>both</a:t>
+            </a:r>
+            <a:r>
+              <a:rPr b="0" i="0" lang="en-US" sz="900" u="none" cap="none" strike="noStrike">
+                <a:solidFill>
+                  <a:srgbClr val="FFFFFF"/>
+                </a:solidFill>
+                <a:latin typeface="Calibri"/>
+                <a:ea typeface="Calibri"/>
+                <a:cs typeface="Calibri"/>
+                <a:sym typeface="Calibri"/>
+              </a:rPr>
+              <a:t> years (2 of only 8 city-wide); affluent-in AND poorer-out both thick, frame-robust. Yee-modal Stable — the flow lens sees what attributes miss.</a:t>
             </a:r>
             <a:endParaRPr b="0" i="0" sz="1050" u="none" cap="none" strike="noStrike">
               <a:solidFill>
@@ -10203,7 +10328,19 @@
                 <a:cs typeface="Calibri"/>
                 <a:sym typeface="Calibri"/>
               </a:rPr>
-              <a:t>C · LADDER ARTEFACT</a:t>
+              <a:t>C · </a:t>
+            </a:r>
+            <a:r>
+              <a:rPr b="1" i="0" lang="en-US" sz="1050" u="none" cap="none" strike="noStrike">
+                <a:solidFill>
+                  <a:srgbClr val="2B2B31"/>
+                </a:solidFill>
+                <a:latin typeface="Calibri"/>
+                <a:ea typeface="Calibri"/>
+                <a:cs typeface="Calibri"/>
+                <a:sym typeface="Calibri"/>
+              </a:rPr>
+              <a:t>LADDER ARTEFACT</a:t>
             </a:r>
             <a:endParaRPr b="0" i="0" sz="1050" u="none" cap="none" strike="noStrike">
               <a:solidFill>
@@ -10747,7 +10884,7 @@
               <a:buNone/>
             </a:pPr>
             <a:r>
-              <a:rPr b="1" i="0" lang="en-US" sz="2500" u="none" cap="none" strike="noStrike">
+              <a:rPr b="1" i="0" lang="en-US" sz="2300" u="none" cap="none" strike="noStrike">
                 <a:solidFill>
                   <a:srgbClr val="2B2B31"/>
                 </a:solidFill>
@@ -10758,7 +10895,7 @@
               </a:rPr>
               <a:t>Why follow the movers?</a:t>
             </a:r>
-            <a:endParaRPr b="0" i="0" sz="2500" u="none" cap="none" strike="noStrike">
+            <a:endParaRPr b="0" i="0" sz="2300" u="none" cap="none" strike="noStrike">
               <a:solidFill>
                 <a:schemeClr val="dk1"/>
               </a:solidFill>
@@ -12006,7 +12143,7 @@
               <a:buNone/>
             </a:pPr>
             <a:r>
-              <a:rPr b="1" i="0" lang="en-US" sz="2500" u="none" cap="none" strike="noStrike">
+              <a:rPr b="1" i="0" lang="en-US" sz="2300" u="none" cap="none" strike="noStrike">
                 <a:solidFill>
                   <a:srgbClr val="2B2B31"/>
                 </a:solidFill>
@@ -12017,7 +12154,7 @@
               </a:rPr>
               <a:t>One fixed ladder, four elementary flows</a:t>
             </a:r>
-            <a:endParaRPr b="0" i="0" sz="2500" u="none" cap="none" strike="noStrike">
+            <a:endParaRPr b="0" i="0" sz="2300" u="none" cap="none" strike="noStrike">
               <a:solidFill>
                 <a:schemeClr val="dk1"/>
               </a:solidFill>
@@ -14298,7 +14435,7 @@
               <a:buNone/>
             </a:pPr>
             <a:r>
-              <a:rPr b="1" i="0" lang="en-US" sz="2500" u="none" cap="none" strike="noStrike">
+              <a:rPr b="1" i="0" lang="en-US" sz="2300" u="none" cap="none" strike="noStrike">
                 <a:solidFill>
                   <a:srgbClr val="2B2B31"/>
                 </a:solidFill>
@@ -14309,7 +14446,7 @@
               </a:rPr>
               <a:t>The classifier: churn → a flow-regime typology</a:t>
             </a:r>
-            <a:endParaRPr b="0" i="0" sz="2500" u="none" cap="none" strike="noStrike">
+            <a:endParaRPr b="0" i="0" sz="2300" u="none" cap="none" strike="noStrike">
               <a:solidFill>
                 <a:schemeClr val="dk1"/>
               </a:solidFill>
@@ -16000,7 +16137,7 @@
               <a:buNone/>
             </a:pPr>
             <a:r>
-              <a:rPr b="1" i="0" lang="en-US" sz="2500" u="none" cap="none" strike="noStrike">
+              <a:rPr b="1" i="0" lang="en-US" sz="2300" u="none" cap="none" strike="noStrike">
                 <a:solidFill>
                   <a:srgbClr val="2B2B31"/>
                 </a:solidFill>
@@ -16011,7 +16148,7 @@
               </a:rPr>
               <a:t>Three frames — London-only stays the core</a:t>
             </a:r>
-            <a:endParaRPr b="0" i="0" sz="2500" u="none" cap="none" strike="noStrike">
+            <a:endParaRPr b="0" i="0" sz="2300" u="none" cap="none" strike="noStrike">
               <a:solidFill>
                 <a:schemeClr val="dk1"/>
               </a:solidFill>
@@ -17334,6 +17471,18 @@
               <a:buNone/>
             </a:pPr>
             <a:r>
+              <a:rPr b="1" i="0" lang="en-US" sz="1150" u="none" cap="none" strike="noStrike">
+                <a:solidFill>
+                  <a:srgbClr val="63636C"/>
+                </a:solidFill>
+                <a:latin typeface="Calibri"/>
+                <a:ea typeface="Calibri"/>
+                <a:cs typeface="Calibri"/>
+                <a:sym typeface="Calibri"/>
+              </a:rPr>
+              <a:t>~69% of London MSOAs sit below national D6:</a:t>
+            </a:r>
+            <a:r>
               <a:rPr b="0" i="0" lang="en-US" sz="1150" u="none" cap="none" strike="noStrike">
                 <a:solidFill>
                   <a:srgbClr val="63636C"/>
@@ -17343,7 +17492,7 @@
                 <a:cs typeface="Calibri"/>
                 <a:sym typeface="Calibri"/>
               </a:rPr>
-              <a:t>~69% of London MSOAs sit below national D6: the national ladder compresses London, so Frame A stays the faithful gentrification lens; C is context. Remember the external channel for later.</a:t>
+              <a:t> the national ladder compresses London, so Frame A stays the faithful gentrification lens; C is context. </a:t>
             </a:r>
             <a:endParaRPr b="0" i="0" sz="1150" u="none" cap="none" strike="noStrike">
               <a:solidFill>
@@ -17624,7 +17773,7 @@
               <a:buNone/>
             </a:pPr>
             <a:r>
-              <a:rPr b="1" i="0" lang="en-US" sz="2500" u="none" cap="none" strike="noStrike">
+              <a:rPr b="1" i="0" lang="en-US" sz="2300" u="none" cap="none" strike="noStrike">
                 <a:solidFill>
                   <a:srgbClr val="2B2B31"/>
                 </a:solidFill>
@@ -17635,7 +17784,7 @@
               </a:rPr>
               <a:t>Three independent checks — on two clocks</a:t>
             </a:r>
-            <a:endParaRPr b="0" i="0" sz="2500" u="none" cap="none" strike="noStrike">
+            <a:endParaRPr b="0" i="0" sz="2300" u="none" cap="none" strike="noStrike">
               <a:solidFill>
                 <a:schemeClr val="dk1"/>
               </a:solidFill>
@@ -18374,7 +18523,31 @@
                 <a:cs typeface="Calibri"/>
                 <a:sym typeface="Calibri"/>
               </a:rPr>
-              <a:t>the established classification — labels built on 2001–2011 change</a:t>
+              <a:t>the established classification</a:t>
+            </a:r>
+            <a:r>
+              <a:rPr lang="en-US" sz="950">
+                <a:solidFill>
+                  <a:srgbClr val="63636C"/>
+                </a:solidFill>
+                <a:latin typeface="Calibri"/>
+                <a:ea typeface="Calibri"/>
+                <a:cs typeface="Calibri"/>
+                <a:sym typeface="Calibri"/>
+              </a:rPr>
+              <a:t>, </a:t>
+            </a:r>
+            <a:r>
+              <a:rPr b="0" i="0" lang="en-US" sz="950" u="none" cap="none" strike="noStrike">
+                <a:solidFill>
+                  <a:srgbClr val="63636C"/>
+                </a:solidFill>
+                <a:latin typeface="Calibri"/>
+                <a:ea typeface="Calibri"/>
+                <a:cs typeface="Calibri"/>
+                <a:sym typeface="Calibri"/>
+              </a:rPr>
+              <a:t> labels built on 2001–2011 change</a:t>
             </a:r>
             <a:endParaRPr b="0" i="0" sz="1150" u="none" cap="none" strike="noStrike">
               <a:solidFill>
@@ -19249,7 +19422,7 @@
               <a:buNone/>
             </a:pPr>
             <a:r>
-              <a:rPr b="1" i="0" lang="en-US" sz="2500" u="none" cap="none" strike="noStrike">
+              <a:rPr b="1" lang="en-US" sz="2300">
                 <a:solidFill>
                   <a:srgbClr val="2B2B31"/>
                 </a:solidFill>
@@ -19258,9 +19431,21 @@
                 <a:cs typeface="Cambria"/>
                 <a:sym typeface="Cambria"/>
               </a:rPr>
-              <a:t>The equivalence fails</a:t>
-            </a:r>
-            <a:endParaRPr b="0" i="0" sz="2500" u="none" cap="none" strike="noStrike">
+              <a:t>Cascade </a:t>
+            </a:r>
+            <a:r>
+              <a:rPr b="1" lang="en-US" sz="2300">
+                <a:solidFill>
+                  <a:srgbClr val="1C2B3A"/>
+                </a:solidFill>
+                <a:latin typeface="Cambria"/>
+                <a:ea typeface="Cambria"/>
+                <a:cs typeface="Cambria"/>
+                <a:sym typeface="Cambria"/>
+              </a:rPr>
+              <a:t>≠ Attribute-defined Gentrification</a:t>
+            </a:r>
+            <a:endParaRPr b="0" i="0" sz="2300" u="none" cap="none" strike="noStrike">
               <a:solidFill>
                 <a:schemeClr val="dk1"/>
               </a:solidFill>
@@ -20776,7 +20961,7 @@
                 <a:cs typeface="Calibri"/>
                 <a:sym typeface="Calibri"/>
               </a:rPr>
-              <a:t>→ A bare null — or did “cascade-led” pool different mechanisms?</a:t>
+              <a:t>→ A bare null? — or did “cascade-led” pool different mechanisms?</a:t>
             </a:r>
             <a:endParaRPr b="0" i="0" sz="950" u="none" cap="none" strike="noStrike">
               <a:solidFill>
@@ -20925,7 +21110,7 @@
               <a:buNone/>
             </a:pPr>
             <a:r>
-              <a:rPr b="1" i="0" lang="en-US" sz="2500" u="none" cap="none" strike="noStrike">
+              <a:rPr b="1" i="0" lang="en-US" sz="2300" u="none" cap="none" strike="noStrike">
                 <a:solidFill>
                   <a:srgbClr val="2B2B31"/>
                 </a:solidFill>
@@ -20934,9 +21119,57 @@
                 <a:cs typeface="Cambria"/>
                 <a:sym typeface="Cambria"/>
               </a:rPr>
-              <a:t>Unpooling the cascade: a time-symmetric mechanism tree</a:t>
-            </a:r>
-            <a:endParaRPr b="0" i="0" sz="2500" u="none" cap="none" strike="noStrike">
+              <a:t>Unpooling </a:t>
+            </a:r>
+            <a:r>
+              <a:rPr b="1" i="0" lang="en-US" sz="2300" u="none" cap="none" strike="noStrike">
+                <a:solidFill>
+                  <a:srgbClr val="2B2B31"/>
+                </a:solidFill>
+                <a:latin typeface="Cambria"/>
+                <a:ea typeface="Cambria"/>
+                <a:cs typeface="Cambria"/>
+                <a:sym typeface="Cambria"/>
+              </a:rPr>
+              <a:t>the</a:t>
+            </a:r>
+            <a:r>
+              <a:rPr b="1" i="0" lang="en-US" sz="2300" u="none" cap="none" strike="noStrike">
+                <a:solidFill>
+                  <a:srgbClr val="2B2B31"/>
+                </a:solidFill>
+                <a:latin typeface="Cambria"/>
+                <a:ea typeface="Cambria"/>
+                <a:cs typeface="Cambria"/>
+                <a:sym typeface="Cambria"/>
+              </a:rPr>
+              <a:t> cascade: a time-symmetric </a:t>
+            </a:r>
+            <a:r>
+              <a:rPr b="1" i="0" lang="en-US" sz="2300" u="none" cap="none" strike="noStrike">
+                <a:solidFill>
+                  <a:srgbClr val="2B2B31"/>
+                </a:solidFill>
+                <a:latin typeface="Cambria"/>
+                <a:ea typeface="Cambria"/>
+                <a:cs typeface="Cambria"/>
+                <a:sym typeface="Cambria"/>
+              </a:rPr>
+              <a:t>mechanism</a:t>
+            </a:r>
+            <a:r>
+              <a:rPr b="1" i="0" lang="en-US" sz="2300" u="none" cap="none" strike="noStrike">
+                <a:solidFill>
+                  <a:srgbClr val="2B2B31"/>
+                </a:solidFill>
+                <a:latin typeface="Cambria"/>
+                <a:ea typeface="Cambria"/>
+                <a:cs typeface="Cambria"/>
+                <a:sym typeface="Cambria"/>
+              </a:rPr>
+              <a:t> tree</a:t>
+            </a:r>
+            <a:endParaRPr b="0" i="0" sz="2300" u="none" cap="none" strike="noStrike">
               <a:solidFill>
                 <a:schemeClr val="dk1"/>
               </a:solidFill>
@@ -22298,8 +22531,8 @@
         </p:nvSpPr>
         <p:spPr>
           <a:xfrm>
-            <a:off x="6949440" y="1426464"/>
-            <a:ext cx="1691640" cy="219456"/>
+            <a:off x="6995165" y="1682489"/>
+            <a:ext cx="1691700" cy="219600"/>
           </a:xfrm>
           <a:prstGeom prst="rect">
             <a:avLst/>
@@ -22747,7 +22980,7 @@
               <a:buNone/>
             </a:pPr>
             <a:r>
-              <a:rPr b="1" i="0" lang="en-US" sz="2500" u="none" cap="none" strike="noStrike">
+              <a:rPr b="1" i="0" lang="en-US" sz="2300" u="none" cap="none" strike="noStrike">
                 <a:solidFill>
                   <a:srgbClr val="2B2B31"/>
                 </a:solidFill>
@@ -22758,7 +22991,7 @@
               </a:rPr>
               <a:t>The leaf-level test: where does Yee’s GEN actually live?</a:t>
             </a:r>
-            <a:endParaRPr b="0" i="0" sz="2500" u="none" cap="none" strike="noStrike">
+            <a:endParaRPr b="0" i="0" sz="2300" u="none" cap="none" strike="noStrike">
               <a:solidFill>
                 <a:schemeClr val="dk1"/>
               </a:solidFill>
@@ -23194,7 +23427,7 @@
                 <a:cs typeface="Calibri"/>
                 <a:sym typeface="Calibri"/>
               </a:rPr>
-              <a:t>enrichment: lift = P(GEN | leaf) / P(GEN), Fisher’s exact test, BH-corrected. (Cramér’s V / ARI retired — swamped by Yee’s 71% Stable base at leaf sample sizes.)</a:t>
+              <a:t>enrichment: lift = P(GEN | leaf) / P(GEN), Fisher’s exact test, BH-corrected. </a:t>
             </a:r>
             <a:endParaRPr b="0" i="0" sz="1050" u="none" cap="none" strike="noStrike">
               <a:solidFill>
@@ -23215,7 +23448,7 @@
           <p:nvPr/>
         </p:nvPicPr>
         <p:blipFill rotWithShape="1">
-          <a:blip r:embed="rId3">
+          <a:blip r:embed="rId4">
             <a:alphaModFix/>
           </a:blip>
           <a:srcRect b="0" l="0" r="0" t="0"/>

</xml_diff>